<commit_message>
Volume II chapters 5-6 assets (seeds 26205, 26206); ch4 deck next-slide fix
</commit_message>
<xml_diff>
--- a/downloads/DCT_V2_Ch04_Slides.pptx
+++ b/downloads/DCT_V2_Ch04_Slides.pptx
@@ -7572,7 +7572,7 @@
                 <a:ea typeface="Calibri" pitchFamily="34" charset="-122"/>
                 <a:cs typeface="Calibri" pitchFamily="34" charset="-120"/>
               </a:rPr>
-              <a:t>Chapters 3–4 optimized snapshots; Chapters 5–6 handle structure and discreteness; from Chapter 7 the CLOCK is load-bearing — decisions become trajectories again</a:t>
+              <a:t>Chapters 3–4 optimized snapshots; from Chapter 5 the CLOCK is load-bearing — decisions become trajectories, and Chapter 6 gives them their maximum principle</a:t>
             </a:r>
             <a:endParaRPr lang="en-US" sz="1450" dirty="0"/>
           </a:p>
@@ -7909,7 +7909,7 @@
                 <a:ea typeface="Calibri" pitchFamily="34" charset="-122"/>
                 <a:cs typeface="Calibri" pitchFamily="34" charset="-120"/>
               </a:rPr>
-              <a:t>Chapter 5 changes the axis: from curvature to STRUCTURE — linear and network optimization, where the enterprise's architecture (Vol. I, Ch. 9) becomes the algorithm's map</a:t>
+              <a:t>Chapter 5 puts the clock back in: dynamic enterprise optimization — trajectories, policies, and intertemporal trade-offs on the certified dynamics</a:t>
             </a:r>
             <a:endParaRPr lang="en-US" sz="1500" dirty="0"/>
           </a:p>
@@ -12244,7 +12244,7 @@
                 <a:ea typeface="Calibri" pitchFamily="34" charset="-122"/>
                 <a:cs typeface="Calibri" pitchFamily="34" charset="-120"/>
               </a:rPr>
-              <a:t>Next class (Week 9–10 → Vol. II Chapter 5): structure over curvature — linear and network enterprise optimization</a:t>
+              <a:t>Next class (Week 10 → Vol. II Chapter 5): the clock returns — dynamic enterprise optimization</a:t>
             </a:r>
             <a:endParaRPr lang="en-US" sz="1550" dirty="0"/>
           </a:p>
@@ -12682,7 +12682,7 @@
                 <a:ea typeface="Georgia" pitchFamily="34" charset="-122"/>
                 <a:cs typeface="Georgia" pitchFamily="34" charset="-120"/>
               </a:rPr>
-              <a:t>Chapter 5 — Linear and Network Enterprise Optimization</a:t>
+              <a:t>Chapter 5 — Dynamic Enterprise Optimization</a:t>
             </a:r>
             <a:endParaRPr lang="en-US" sz="2700" dirty="0"/>
           </a:p>
@@ -12725,7 +12725,7 @@
                 <a:ea typeface="Calibri" pitchFamily="34" charset="-122"/>
                 <a:cs typeface="Calibri" pitchFamily="34" charset="-120"/>
               </a:rPr>
-              <a:t>Structure as the algorithm's map: LP at scale</a:t>
+              <a:t>Trajectories, policies, and intertemporal trade-offs</a:t>
             </a:r>
             <a:endParaRPr lang="en-US" sz="1600" dirty="0"/>
           </a:p>
@@ -12746,7 +12746,7 @@
                 <a:ea typeface="Calibri" pitchFamily="34" charset="-122"/>
                 <a:cs typeface="Calibri" pitchFamily="34" charset="-120"/>
               </a:rPr>
-              <a:t>Volume I's dependency graph becomes a flow network</a:t>
+              <a:t>Neither myopia nor maximal patience: the switching optimum</a:t>
             </a:r>
             <a:endParaRPr lang="en-US" sz="1600" dirty="0"/>
           </a:p>
@@ -12767,7 +12767,7 @@
                 <a:ea typeface="Calibri" pitchFamily="34" charset="-122"/>
                 <a:cs typeface="Calibri" pitchFamily="34" charset="-120"/>
               </a:rPr>
-              <a:t>Simplex, interior points, and network specializations</a:t>
+              <a:t>Plans remember; policies see — the shock test</a:t>
             </a:r>
             <a:endParaRPr lang="en-US" sz="1600" dirty="0"/>
           </a:p>

</xml_diff>